<commit_message>
camb img carta pres
</commit_message>
<xml_diff>
--- a/public/Carta de Presentación.pptx
+++ b/public/Carta de Presentación.pptx
@@ -3335,7 +3335,7 @@
         </p:nvSpPr>
         <p:spPr>
           <a:xfrm>
-            <a:off x="838200" y="113121"/>
+            <a:off x="838200" y="113120"/>
             <a:ext cx="10515600" cy="6744880"/>
           </a:xfrm>
         </p:spPr>
@@ -3393,7 +3393,7 @@
             </a:pPr>
             <a:r>
               <a:rPr lang="es-MX" sz="1500" b="1" dirty="0"/>
-              <a:t>Estimado equipo de reclutamiento:</a:t>
+              <a:t>Estimado equipo de reclutamiento: </a:t>
             </a:r>
             <a:endParaRPr lang="es-MX" sz="1500" dirty="0"/>
           </a:p>
@@ -3494,32 +3494,29 @@
             <a:pPr>
               <a:buNone/>
             </a:pPr>
+            <a:endParaRPr lang="es-MX" sz="1500" dirty="0"/>
+          </a:p>
+          <a:p>
+            <a:pPr>
+              <a:buNone/>
+            </a:pPr>
+            <a:r>
+              <a:rPr lang="es-MX" sz="1500" dirty="0"/>
+              <a:t>Atentamente,</a:t>
+            </a:r>
+          </a:p>
+          <a:p>
+            <a:pPr>
+              <a:buNone/>
+            </a:pPr>
             <a:r>
               <a:rPr lang="es-MX" sz="1500" b="1" dirty="0"/>
-              <a:t>Atentamente,</a:t>
-            </a:r>
-          </a:p>
-          <a:p>
-            <a:pPr>
-              <a:buNone/>
-            </a:pPr>
-            <a:endParaRPr lang="es-MX" sz="1500" dirty="0"/>
-          </a:p>
-          <a:p>
-            <a:pPr>
-              <a:buNone/>
-            </a:pPr>
-            <a:endParaRPr lang="es-MX" sz="1500" dirty="0"/>
-          </a:p>
-          <a:p>
-            <a:pPr>
-              <a:buNone/>
-            </a:pPr>
-            <a:r>
-              <a:rPr lang="es-MX" sz="1500" b="1" dirty="0"/>
+              <a:t>		</a:t>
+            </a:r>
+            <a:r>
+              <a:rPr lang="es-MX" sz="1500" dirty="0"/>
               <a:t>Arturo Juárez Monroy</a:t>
             </a:r>
-            <a:endParaRPr lang="es-MX" sz="1500" dirty="0"/>
           </a:p>
           <a:p>
             <a:endParaRPr lang="es-MX" dirty="0"/>
@@ -3650,7 +3647,7 @@
         </p:blipFill>
         <p:spPr>
           <a:xfrm>
-            <a:off x="2925017" y="6117273"/>
+            <a:off x="3754576" y="6013579"/>
             <a:ext cx="1161800" cy="627606"/>
           </a:xfrm>
           <a:prstGeom prst="rect">

</xml_diff>

<commit_message>
chat ubicacion y carta de presentacion
</commit_message>
<xml_diff>
--- a/public/Carta de Presentación.pptx
+++ b/public/Carta de Presentación.pptx
@@ -275,7 +275,7 @@
           <a:p>
             <a:fld id="{4E370992-1CAB-4810-8415-DC9E05727B44}" type="datetimeFigureOut">
               <a:rPr lang="es-MX" smtClean="0"/>
-              <a:t>28/06/2026</a:t>
+              <a:t>17/07/2026</a:t>
             </a:fld>
             <a:endParaRPr lang="es-MX"/>
           </a:p>
@@ -445,7 +445,7 @@
           <a:p>
             <a:fld id="{4E370992-1CAB-4810-8415-DC9E05727B44}" type="datetimeFigureOut">
               <a:rPr lang="es-MX" smtClean="0"/>
-              <a:t>28/06/2026</a:t>
+              <a:t>17/07/2026</a:t>
             </a:fld>
             <a:endParaRPr lang="es-MX"/>
           </a:p>
@@ -625,7 +625,7 @@
           <a:p>
             <a:fld id="{4E370992-1CAB-4810-8415-DC9E05727B44}" type="datetimeFigureOut">
               <a:rPr lang="es-MX" smtClean="0"/>
-              <a:t>28/06/2026</a:t>
+              <a:t>17/07/2026</a:t>
             </a:fld>
             <a:endParaRPr lang="es-MX"/>
           </a:p>
@@ -795,7 +795,7 @@
           <a:p>
             <a:fld id="{4E370992-1CAB-4810-8415-DC9E05727B44}" type="datetimeFigureOut">
               <a:rPr lang="es-MX" smtClean="0"/>
-              <a:t>28/06/2026</a:t>
+              <a:t>17/07/2026</a:t>
             </a:fld>
             <a:endParaRPr lang="es-MX"/>
           </a:p>
@@ -1063,7 +1063,7 @@
           <a:p>
             <a:fld id="{4E370992-1CAB-4810-8415-DC9E05727B44}" type="datetimeFigureOut">
               <a:rPr lang="es-MX" smtClean="0"/>
-              <a:t>28/06/2026</a:t>
+              <a:t>17/07/2026</a:t>
             </a:fld>
             <a:endParaRPr lang="es-MX"/>
           </a:p>
@@ -1295,7 +1295,7 @@
           <a:p>
             <a:fld id="{4E370992-1CAB-4810-8415-DC9E05727B44}" type="datetimeFigureOut">
               <a:rPr lang="es-MX" smtClean="0"/>
-              <a:t>28/06/2026</a:t>
+              <a:t>17/07/2026</a:t>
             </a:fld>
             <a:endParaRPr lang="es-MX"/>
           </a:p>
@@ -1650,7 +1650,7 @@
           <a:p>
             <a:fld id="{4E370992-1CAB-4810-8415-DC9E05727B44}" type="datetimeFigureOut">
               <a:rPr lang="es-MX" smtClean="0"/>
-              <a:t>28/06/2026</a:t>
+              <a:t>17/07/2026</a:t>
             </a:fld>
             <a:endParaRPr lang="es-MX"/>
           </a:p>
@@ -1791,7 +1791,7 @@
           <a:p>
             <a:fld id="{4E370992-1CAB-4810-8415-DC9E05727B44}" type="datetimeFigureOut">
               <a:rPr lang="es-MX" smtClean="0"/>
-              <a:t>28/06/2026</a:t>
+              <a:t>17/07/2026</a:t>
             </a:fld>
             <a:endParaRPr lang="es-MX"/>
           </a:p>
@@ -1886,7 +1886,7 @@
           <a:p>
             <a:fld id="{4E370992-1CAB-4810-8415-DC9E05727B44}" type="datetimeFigureOut">
               <a:rPr lang="es-MX" smtClean="0"/>
-              <a:t>28/06/2026</a:t>
+              <a:t>17/07/2026</a:t>
             </a:fld>
             <a:endParaRPr lang="es-MX"/>
           </a:p>
@@ -2248,7 +2248,7 @@
           <a:p>
             <a:fld id="{4E370992-1CAB-4810-8415-DC9E05727B44}" type="datetimeFigureOut">
               <a:rPr lang="es-MX" smtClean="0"/>
-              <a:t>28/06/2026</a:t>
+              <a:t>17/07/2026</a:t>
             </a:fld>
             <a:endParaRPr lang="es-MX"/>
           </a:p>
@@ -2610,7 +2610,7 @@
           <a:p>
             <a:fld id="{4E370992-1CAB-4810-8415-DC9E05727B44}" type="datetimeFigureOut">
               <a:rPr lang="es-MX" smtClean="0"/>
-              <a:t>28/06/2026</a:t>
+              <a:t>17/07/2026</a:t>
             </a:fld>
             <a:endParaRPr lang="es-MX"/>
           </a:p>
@@ -2854,7 +2854,7 @@
           <a:p>
             <a:fld id="{4E370992-1CAB-4810-8415-DC9E05727B44}" type="datetimeFigureOut">
               <a:rPr lang="es-MX" smtClean="0"/>
-              <a:t>28/06/2026</a:t>
+              <a:t>17/07/2026</a:t>
             </a:fld>
             <a:endParaRPr lang="es-MX"/>
           </a:p>
@@ -3341,7 +3341,7 @@
         </p:spPr>
         <p:txBody>
           <a:bodyPr>
-            <a:normAutofit lnSpcReduction="10000"/>
+            <a:normAutofit fontScale="92500" lnSpcReduction="20000"/>
           </a:bodyPr>
           <a:lstStyle/>
           <a:p>
@@ -3349,23 +3349,32 @@
               <a:buNone/>
             </a:pPr>
             <a:r>
-              <a:rPr lang="es-MX" sz="1400" dirty="0">
+              <a:rPr lang="es-MX" sz="2000" dirty="0">
                 <a:latin typeface="Segoe UI Variable Small" pitchFamily="2" charset="0"/>
               </a:rPr>
-              <a:t>Pachuca de Soto, Hidalgo, México </a:t>
-            </a:r>
+              <a:t>Pachuca de Soto</a:t>
+            </a:r>
+            <a:r>
+              <a:rPr lang="es-MX" sz="2000">
+                <a:latin typeface="Segoe UI Variable Small" pitchFamily="2" charset="0"/>
+              </a:rPr>
+              <a:t>, Hidalgo.</a:t>
+            </a:r>
+            <a:endParaRPr lang="es-MX" sz="2000" dirty="0">
+              <a:latin typeface="Segoe UI Variable Small" pitchFamily="2" charset="0"/>
+            </a:endParaRPr>
           </a:p>
           <a:p>
             <a:pPr>
               <a:buNone/>
             </a:pPr>
             <a:r>
-              <a:rPr lang="es-MX" sz="1400" dirty="0">
+              <a:rPr lang="es-MX" sz="2000" dirty="0">
                 <a:latin typeface="Segoe UI Variable Small" pitchFamily="2" charset="0"/>
               </a:rPr>
               <a:t>03 Abril, 2026</a:t>
             </a:r>
-            <a:endParaRPr lang="es-MX" sz="1200" dirty="0">
+            <a:endParaRPr lang="es-MX" dirty="0">
               <a:latin typeface="Segoe UI Variable Small" pitchFamily="2" charset="0"/>
             </a:endParaRPr>
           </a:p>
@@ -3374,7 +3383,7 @@
               <a:buNone/>
             </a:pPr>
             <a:r>
-              <a:rPr lang="es-MX" sz="1400" b="1" dirty="0">
+              <a:rPr lang="es-MX" sz="2000" b="1" dirty="0">
                 <a:latin typeface="Segoe UI Variable Small" pitchFamily="2" charset="0"/>
               </a:rPr>
               <a:t>CARTA DE PRESENTACIÓN</a:t>
@@ -3385,7 +3394,7 @@
               <a:buNone/>
             </a:pPr>
             <a:r>
-              <a:rPr lang="es-MX" sz="1400" b="1" dirty="0">
+              <a:rPr lang="es-MX" sz="2000" b="1" dirty="0">
                 <a:latin typeface="Segoe UI Variable Small" pitchFamily="2" charset="0"/>
               </a:rPr>
               <a:t>Departamento de Recursos Humanos</a:t>
@@ -3395,7 +3404,7 @@
             <a:pPr algn="ctr">
               <a:buNone/>
             </a:pPr>
-            <a:endParaRPr lang="es-MX" sz="1400" dirty="0">
+            <a:endParaRPr lang="es-MX" sz="2000" dirty="0">
               <a:latin typeface="Segoe UI Variable Small" pitchFamily="2" charset="0"/>
             </a:endParaRPr>
           </a:p>
@@ -3404,12 +3413,12 @@
               <a:buNone/>
             </a:pPr>
             <a:r>
-              <a:rPr lang="es-MX" sz="1400" b="1" dirty="0">
+              <a:rPr lang="es-MX" sz="2000" b="1" dirty="0">
                 <a:latin typeface="Segoe UI Variable Small" pitchFamily="2" charset="0"/>
               </a:rPr>
               <a:t>Estimado equipo de reclutamiento: </a:t>
             </a:r>
-            <a:endParaRPr lang="es-MX" sz="1400" dirty="0">
+            <a:endParaRPr lang="es-MX" sz="2000" dirty="0">
               <a:latin typeface="Segoe UI Variable Small" pitchFamily="2" charset="0"/>
             </a:endParaRPr>
           </a:p>
@@ -3418,43 +3427,43 @@
               <a:buNone/>
             </a:pPr>
             <a:r>
-              <a:rPr lang="es-MX" sz="1400" dirty="0">
+              <a:rPr lang="es-MX" sz="2000" dirty="0">
                 <a:latin typeface="Segoe UI Variable Small" pitchFamily="2" charset="0"/>
               </a:rPr>
               <a:t>Soy ingeniero de software con experiencia en el desarrollo integral de aplicaciones web, específicamente en el desarrollo </a:t>
             </a:r>
             <a:r>
-              <a:rPr lang="es-MX" sz="1400" dirty="0" err="1">
+              <a:rPr lang="es-MX" sz="2000" dirty="0" err="1">
                 <a:latin typeface="Segoe UI Variable Small" pitchFamily="2" charset="0"/>
               </a:rPr>
               <a:t>backend</a:t>
             </a:r>
             <a:r>
-              <a:rPr lang="es-MX" sz="1400" dirty="0">
+              <a:rPr lang="es-MX" sz="2000" dirty="0">
                 <a:latin typeface="Segoe UI Variable Small" pitchFamily="2" charset="0"/>
               </a:rPr>
               <a:t> utilizando Java, Spring Boot y SQL. Mi experiencia abarca el desarrollo de API REST, la implementación de lógica de negocio, la integración de bases de datos, la creación de paneles de administración y el trabajo con arquitecturas en capas y el patrón MVC. También disfruto realizar desarrollo </a:t>
             </a:r>
             <a:r>
-              <a:rPr lang="es-MX" sz="1400" dirty="0" err="1">
+              <a:rPr lang="es-MX" sz="2000" dirty="0" err="1">
                 <a:latin typeface="Segoe UI Variable Small" pitchFamily="2" charset="0"/>
               </a:rPr>
               <a:t>frontend</a:t>
             </a:r>
             <a:r>
-              <a:rPr lang="es-MX" sz="1400" dirty="0">
+              <a:rPr lang="es-MX" sz="2000" dirty="0">
                 <a:latin typeface="Segoe UI Variable Small" pitchFamily="2" charset="0"/>
               </a:rPr>
               <a:t> con </a:t>
             </a:r>
             <a:r>
-              <a:rPr lang="es-MX" sz="1400" dirty="0" err="1">
+              <a:rPr lang="es-MX" sz="2000" dirty="0" err="1">
                 <a:latin typeface="Segoe UI Variable Small" pitchFamily="2" charset="0"/>
               </a:rPr>
               <a:t>React</a:t>
             </a:r>
             <a:r>
-              <a:rPr lang="es-MX" sz="1400" dirty="0">
+              <a:rPr lang="es-MX" sz="2000" dirty="0">
                 <a:latin typeface="Segoe UI Variable Small" pitchFamily="2" charset="0"/>
               </a:rPr>
               <a:t>, Angular y Tailwind. </a:t>
@@ -3465,53 +3474,7 @@
               <a:buNone/>
             </a:pPr>
             <a:r>
-              <a:rPr lang="es-MX" sz="1400" dirty="0">
-                <a:latin typeface="Segoe UI Variable Small" pitchFamily="2" charset="0"/>
-              </a:rPr>
-              <a:t>He colaborado en proyectos de sectores público, privado y financiero, aplicando buenas prácticas de desarrollo y utilizando Git para el control de versiones y la gestión colaborativa del código.</a:t>
-            </a:r>
-          </a:p>
-          <a:p>
-            <a:pPr>
-              <a:buNone/>
-            </a:pPr>
-            <a:r>
-              <a:rPr lang="es-MX" sz="1400" dirty="0">
-                <a:latin typeface="Segoe UI Variable Small" pitchFamily="2" charset="0"/>
-              </a:rPr>
-              <a:t>De forma paralela, desarrollo proyectos personales con el objetivo de seguir aprendiendo nuevas tecnologías y fortalecer mis conocimientos en desarrollo de software, arquitectura de aplicaciones y resolución de problemas. Entre ellos destaca “Starlight: No </a:t>
-            </a:r>
-            <a:r>
-              <a:rPr lang="es-MX" sz="1400" dirty="0" err="1">
-                <a:latin typeface="Segoe UI Variable Small" pitchFamily="2" charset="0"/>
-              </a:rPr>
-              <a:t>Return</a:t>
-            </a:r>
-            <a:r>
-              <a:rPr lang="es-MX" sz="1400" dirty="0">
-                <a:latin typeface="Segoe UI Variable Small" pitchFamily="2" charset="0"/>
-              </a:rPr>
-              <a:t>”, un videojuego arcade para navegador desarrollado con JavaScript ES6, </a:t>
-            </a:r>
-            <a:r>
-              <a:rPr lang="es-MX" sz="1400" dirty="0" err="1">
-                <a:latin typeface="Segoe UI Variable Small" pitchFamily="2" charset="0"/>
-              </a:rPr>
-              <a:t>Canvas</a:t>
-            </a:r>
-            <a:r>
-              <a:rPr lang="es-MX" sz="1400" dirty="0">
-                <a:latin typeface="Segoe UI Variable Small" pitchFamily="2" charset="0"/>
-              </a:rPr>
-              <a:t> 2D, CSS3 y Web Audio API.</a:t>
-            </a:r>
-          </a:p>
-          <a:p>
-            <a:pPr>
-              <a:buNone/>
-            </a:pPr>
-            <a:r>
-              <a:rPr lang="es-MX" sz="1400" dirty="0">
+              <a:rPr lang="es-MX" sz="2000" dirty="0">
                 <a:latin typeface="Segoe UI Variable Small" pitchFamily="2" charset="0"/>
               </a:rPr>
               <a:t>Me considero una persona responsable, creativa y comprometida con el aprendizaje continuo. Disfruto diseñar y desarrollar soluciones con código mantenible, una arquitectura sólida y un enfoque constante en la calidad del software.</a:t>
@@ -3522,7 +3485,7 @@
               <a:buNone/>
             </a:pPr>
             <a:r>
-              <a:rPr lang="es-MX" sz="1400" dirty="0">
+              <a:rPr lang="es-MX" sz="2000" dirty="0">
                 <a:latin typeface="Segoe UI Variable Small" pitchFamily="2" charset="0"/>
               </a:rPr>
               <a:t>Agradezco el tiempo dedicado a revisar mi perfil y quedo a su disposición para conversar sobre cómo puedo contribuir al cumplimiento de los objetivos de su organización.</a:t>
@@ -3532,7 +3495,7 @@
             <a:pPr>
               <a:buNone/>
             </a:pPr>
-            <a:endParaRPr lang="es-MX" sz="1400" dirty="0">
+            <a:endParaRPr lang="es-MX" sz="2000" dirty="0">
               <a:latin typeface="Segoe UI Variable Small" pitchFamily="2" charset="0"/>
             </a:endParaRPr>
           </a:p>
@@ -3541,7 +3504,7 @@
               <a:buNone/>
             </a:pPr>
             <a:r>
-              <a:rPr lang="es-MX" sz="1400" dirty="0">
+              <a:rPr lang="es-MX" sz="2000" dirty="0">
                 <a:latin typeface="Segoe UI Variable Small" pitchFamily="2" charset="0"/>
               </a:rPr>
               <a:t>Atentamente,</a:t>
@@ -3552,13 +3515,13 @@
               <a:buNone/>
             </a:pPr>
             <a:r>
-              <a:rPr lang="es-MX" sz="1400" b="1" dirty="0">
+              <a:rPr lang="es-MX" sz="2000" b="1" dirty="0">
                 <a:latin typeface="Segoe UI Variable Small" pitchFamily="2" charset="0"/>
               </a:rPr>
               <a:t>		</a:t>
             </a:r>
             <a:r>
-              <a:rPr lang="es-MX" sz="1400" dirty="0">
+              <a:rPr lang="es-MX" sz="2000" dirty="0">
                 <a:latin typeface="Segoe UI Variable Small" pitchFamily="2" charset="0"/>
               </a:rPr>
               <a:t>Arturo Juárez Monroy </a:t>

</xml_diff>